<commit_message>
Update Fakeeh presentation to Dubai/UAE context
</commit_message>
<xml_diff>
--- a/Amigo_x_Fakeeh_v2.pptx
+++ b/Amigo_x_Fakeeh_v2.pptx
@@ -6493,7 +6493,7 @@
                   <a:srgbClr val="C8D0D8"/>
                 </a:solidFill>
               </a:rPr>
-              <a:t>Saudi Arabia's leading private healthcare conglomerate — founded 1978, listed 2024.</a:t>
+              <a:t>Dubai-based private healthcare conglomerate with regional leadership — founded 1978, listed 2024.</a:t>
             </a:r>
           </a:p>
         </p:txBody>
@@ -7456,7 +7456,7 @@
                   <a:srgbClr val="C8D0D8"/>
                 </a:solidFill>
               </a:rPr>
-              <a:t>→  Founded 1978 by Dr. Soliman Fakeeh — Jeddah's first private hospital</a:t>
+              <a:t>→  Founded 1978 by Dr. Soliman Fakeeh — Saudi Arabia's first private hospital</a:t>
             </a:r>
           </a:p>
           <a:p>
@@ -7486,7 +7486,7 @@
                   <a:srgbClr val="C8D0D8"/>
                 </a:solidFill>
               </a:rPr>
-              <a:t>→  CAP Lab: zero deficiencies | CEBAHI &amp; Saudi Commission accredited</a:t>
+              <a:t>→  CAP Lab: zero deficiencies | CEBAHI accredited</a:t>
             </a:r>
           </a:p>
           <a:p>
@@ -7501,7 +7501,7 @@
                   <a:srgbClr val="C8D0D8"/>
                 </a:solidFill>
               </a:rPr>
-              <a:t>→  #1 private hospital in Saudi Arabia — Newsweek 2022–2025</a:t>
+              <a:t>→  Fakeeh University Hospital — flagship Dubai facility (Dubai Silicon Oasis)</a:t>
             </a:r>
           </a:p>
           <a:p>
@@ -7516,7 +7516,7 @@
                   <a:srgbClr val="C8D0D8"/>
                 </a:solidFill>
               </a:rPr>
-              <a:t>→  First private-sector robotic surgery program in Saudi Arabia</a:t>
+              <a:t>→  First private-sector robotic surgery program in the GCC</a:t>
             </a:r>
           </a:p>
           <a:p>
@@ -7531,7 +7531,7 @@
                   <a:srgbClr val="C8D0D8"/>
                 </a:solidFill>
               </a:rPr>
-              <a:t>→  Largest NICU in Western Province | 1st IVF &amp; 1st heart transplant (West KSA)</a:t>
+              <a:t>→  Medicentres acquisition — 22-clinic primary care network across Dubai &amp; UAE</a:t>
             </a:r>
           </a:p>
         </p:txBody>
@@ -7706,7 +7706,7 @@
                   <a:srgbClr val="C8D0D8"/>
                 </a:solidFill>
               </a:rPr>
-              <a:t>→  HEAL Hospital (SAR 461M Neuroscience centre) — construction 2025</a:t>
+              <a:t>→  HEAL Hospital (AED 500M+ Neuroscience centre) — construction underway 2025</a:t>
             </a:r>
           </a:p>
           <a:p>
@@ -7721,7 +7721,7 @@
                   <a:srgbClr val="C8D0D8"/>
                 </a:solidFill>
               </a:rPr>
-              <a:t>→  DSFH Madinah opened 2025 — city's first advanced oncology centre</a:t>
+              <a:t>→  Expanding oncology &amp; tertiary care across Dubai and the Northern Emirates</a:t>
             </a:r>
           </a:p>
           <a:p>
@@ -7736,7 +7736,7 @@
                   <a:srgbClr val="C8D0D8"/>
                 </a:solidFill>
               </a:rPr>
-              <a:t>→  Acquired Saudia Airlines Medical Services (KSA's 1st govt. privatization)</a:t>
+              <a:t>→  Partnership with Dubai Health Authority &amp; DHA-accredited facilities</a:t>
             </a:r>
           </a:p>
           <a:p>
@@ -7751,7 +7751,7 @@
                   <a:srgbClr val="C8D0D8"/>
                 </a:solidFill>
               </a:rPr>
-              <a:t>→  SAR 938M Alinma Bank credit facility secured for expansion</a:t>
+              <a:t>→  AED credit facility secured for GCC-wide expansion</a:t>
             </a:r>
           </a:p>
           <a:p>
@@ -7766,7 +7766,7 @@
                   <a:srgbClr val="C8D0D8"/>
                 </a:solidFill>
               </a:rPr>
-              <a:t>→  UAE: Fakeeh University Hospital + Medicentres acquisition (Dubai)</a:t>
+              <a:t>→  Headquarters: Dubai Silicon Oasis — positioned as UAE's healthcare hub</a:t>
             </a:r>
           </a:p>
         </p:txBody>
@@ -8939,7 +8939,7 @@
                   <a:srgbClr val="C8D0D8"/>
                 </a:solidFill>
               </a:rPr>
-              <a:t>Jeddah serves a diverse population requiring care in Arabic dialects, English, Urdu, Tagalog and more — across all Fakeeh facilities.</a:t>
+              <a:t>Dubai serves a diverse population requiring care in Arabic, English, Urdu, Tagalog, Hindi and more — across all Fakeeh facilities.</a:t>
             </a:r>
           </a:p>
         </p:txBody>
@@ -12485,7 +12485,7 @@
                   <a:srgbClr val="1A1A1A"/>
                 </a:solidFill>
               </a:rPr>
-              <a:t>Ahmed's chronic care journey at Fakeeh</a:t>
+              <a:t>Ahmed's chronic care journey at Fakeeh University Hospital, Dubai</a:t>
             </a:r>
           </a:p>
         </p:txBody>
@@ -12519,7 +12519,7 @@
                   <a:srgbClr val="5A6A7A"/>
                 </a:solidFill>
               </a:rPr>
-              <a:t>Ahmed, 58  ·  Diabetic &amp; hypertensive  ·  Regular DSFH Jeddah patient</a:t>
+              <a:t>Ahmed, 58  ·  Diabetic &amp; hypertensive  ·  Regular Fakeeh University Hospital patient, Dubai</a:t>
             </a:r>
           </a:p>
         </p:txBody>
@@ -13051,7 +13051,7 @@
                   <a:srgbClr val="2C3E50"/>
                 </a:solidFill>
               </a:rPr>
-              <a:t>"Ahmed, you're overdue for a diabetes check. I've found a slot Thursday at DSFH. Want me to book it?"</a:t>
+              <a:t>"Ahmed, you're overdue for a diabetes check. I've found a slot Thursday at Fakeeh University Hospital. Want me to book it?"</a:t>
             </a:r>
           </a:p>
         </p:txBody>
@@ -13119,7 +13119,7 @@
                   <a:srgbClr val="2C3E50"/>
                 </a:solidFill>
               </a:rPr>
-              <a:t>Dr. Al-Rashidi reviews Ahmed's full history, flagged care gaps, and new HbA1c concerns before entering.</a:t>
+              <a:t>Dr. Al-Mansoori reviews Ahmed's full history, flagged care gaps, and new HbA1c concerns before entering.</a:t>
             </a:r>
           </a:p>
         </p:txBody>
@@ -16887,7 +16887,7 @@
                   <a:srgbClr val="963324"/>
                 </a:solidFill>
               </a:rPr>
-              <a:t>🇸🇦  Amigo has an active partnership with Heal (KSA/UAE) — proven GCC deployment track. Arabic-first, 100+ languages, HIPAA · SOC 2 · GDPR compliant.</a:t>
+              <a:t>🇦🇪  Amigo has an active partnership with Heal (UAE/GCC) — proven regional deployment track. Arabic-first, 100+ languages, HIPAA · SOC 2 · GDPR compliant.</a:t>
             </a:r>
           </a:p>
         </p:txBody>

</xml_diff>

<commit_message>
Remove orange footer banners from all slides
</commit_message>
<xml_diff>
--- a/Amigo_x_Fakeeh_v2.pptx
+++ b/Amigo_x_Fakeeh_v2.pptx
@@ -6086,83 +6086,6 @@
           </a:p>
         </p:txBody>
       </p:sp>
-      <p:sp>
-        <p:nvSpPr>
-          <p:cNvPr id="60" name="Rectangle 59"/>
-          <p:cNvSpPr/>
-          <p:nvPr/>
-        </p:nvSpPr>
-        <p:spPr>
-          <a:xfrm>
-            <a:off x="0" y="6537960"/>
-            <a:ext cx="12188952" cy="320040"/>
-          </a:xfrm>
-          <a:prstGeom prst="rect">
-            <a:avLst/>
-          </a:prstGeom>
-          <a:solidFill>
-            <a:srgbClr val="B44030"/>
-          </a:solidFill>
-          <a:ln>
-            <a:noFill/>
-          </a:ln>
-        </p:spPr>
-        <p:style>
-          <a:lnRef idx="1">
-            <a:schemeClr val="accent1"/>
-          </a:lnRef>
-          <a:fillRef idx="3">
-            <a:schemeClr val="accent1"/>
-          </a:fillRef>
-          <a:effectRef idx="2">
-            <a:schemeClr val="accent1"/>
-          </a:effectRef>
-          <a:fontRef idx="minor">
-            <a:schemeClr val="lt1"/>
-          </a:fontRef>
-        </p:style>
-        <p:txBody>
-          <a:bodyPr rtlCol="0" anchor="ctr"/>
-          <a:lstStyle/>
-          <a:p>
-            <a:pPr algn="ctr"/>
-          </a:p>
-        </p:txBody>
-      </p:sp>
-      <p:sp>
-        <p:nvSpPr>
-          <p:cNvPr id="61" name="TextBox 60"/>
-          <p:cNvSpPr txBox="1"/>
-          <p:nvPr/>
-        </p:nvSpPr>
-        <p:spPr>
-          <a:xfrm>
-            <a:off x="365760" y="6565392"/>
-            <a:ext cx="11430000" cy="256032"/>
-          </a:xfrm>
-          <a:prstGeom prst="rect">
-            <a:avLst/>
-          </a:prstGeom>
-          <a:noFill/>
-        </p:spPr>
-        <p:txBody>
-          <a:bodyPr wrap="square">
-            <a:spAutoFit/>
-          </a:bodyPr>
-          <a:lstStyle/>
-          <a:p>
-            <a:pPr algn="ctr"/>
-            <a:r>
-              <a:rPr sz="800" b="0" i="0">
-                <a:solidFill>
-                  <a:srgbClr val="FFFFFF"/>
-                </a:solidFill>
-              </a:rPr>
-              <a:t>amigo.ai  ·  Backed by General Catalyst, GSV Ventures, Madrona Ventures &amp; United Healthcare  ·  $20M raised</a:t>
-            </a:r>
-          </a:p>
-        </p:txBody>
-      </p:sp>
     </p:spTree>
   </p:cSld>
   <p:clrMapOvr>
@@ -7771,83 +7694,6 @@
           </a:p>
         </p:txBody>
       </p:sp>
-      <p:sp>
-        <p:nvSpPr>
-          <p:cNvPr id="39" name="Rectangle 38"/>
-          <p:cNvSpPr/>
-          <p:nvPr/>
-        </p:nvSpPr>
-        <p:spPr>
-          <a:xfrm>
-            <a:off x="0" y="6537960"/>
-            <a:ext cx="12188952" cy="320040"/>
-          </a:xfrm>
-          <a:prstGeom prst="rect">
-            <a:avLst/>
-          </a:prstGeom>
-          <a:solidFill>
-            <a:srgbClr val="B44030"/>
-          </a:solidFill>
-          <a:ln>
-            <a:noFill/>
-          </a:ln>
-        </p:spPr>
-        <p:style>
-          <a:lnRef idx="1">
-            <a:schemeClr val="accent1"/>
-          </a:lnRef>
-          <a:fillRef idx="3">
-            <a:schemeClr val="accent1"/>
-          </a:fillRef>
-          <a:effectRef idx="2">
-            <a:schemeClr val="accent1"/>
-          </a:effectRef>
-          <a:fontRef idx="minor">
-            <a:schemeClr val="lt1"/>
-          </a:fontRef>
-        </p:style>
-        <p:txBody>
-          <a:bodyPr rtlCol="0" anchor="ctr"/>
-          <a:lstStyle/>
-          <a:p>
-            <a:pPr algn="ctr"/>
-          </a:p>
-        </p:txBody>
-      </p:sp>
-      <p:sp>
-        <p:nvSpPr>
-          <p:cNvPr id="40" name="TextBox 39"/>
-          <p:cNvSpPr txBox="1"/>
-          <p:nvPr/>
-        </p:nvSpPr>
-        <p:spPr>
-          <a:xfrm>
-            <a:off x="365760" y="6565392"/>
-            <a:ext cx="11430000" cy="256032"/>
-          </a:xfrm>
-          <a:prstGeom prst="rect">
-            <a:avLst/>
-          </a:prstGeom>
-          <a:noFill/>
-        </p:spPr>
-        <p:txBody>
-          <a:bodyPr wrap="square">
-            <a:spAutoFit/>
-          </a:bodyPr>
-          <a:lstStyle/>
-          <a:p>
-            <a:pPr algn="ctr"/>
-            <a:r>
-              <a:rPr sz="800" b="0" i="0">
-                <a:solidFill>
-                  <a:srgbClr val="FFFFFF"/>
-                </a:solidFill>
-              </a:rPr>
-              <a:t>amigo.ai</a:t>
-            </a:r>
-          </a:p>
-        </p:txBody>
-      </p:sp>
     </p:spTree>
   </p:cSld>
   <p:clrMapOvr>
@@ -9816,83 +9662,6 @@
           </a:p>
         </p:txBody>
       </p:sp>
-      <p:sp>
-        <p:nvSpPr>
-          <p:cNvPr id="53" name="Rectangle 52"/>
-          <p:cNvSpPr/>
-          <p:nvPr/>
-        </p:nvSpPr>
-        <p:spPr>
-          <a:xfrm>
-            <a:off x="0" y="6537960"/>
-            <a:ext cx="12188952" cy="320040"/>
-          </a:xfrm>
-          <a:prstGeom prst="rect">
-            <a:avLst/>
-          </a:prstGeom>
-          <a:solidFill>
-            <a:srgbClr val="B44030"/>
-          </a:solidFill>
-          <a:ln>
-            <a:noFill/>
-          </a:ln>
-        </p:spPr>
-        <p:style>
-          <a:lnRef idx="1">
-            <a:schemeClr val="accent1"/>
-          </a:lnRef>
-          <a:fillRef idx="3">
-            <a:schemeClr val="accent1"/>
-          </a:fillRef>
-          <a:effectRef idx="2">
-            <a:schemeClr val="accent1"/>
-          </a:effectRef>
-          <a:fontRef idx="minor">
-            <a:schemeClr val="lt1"/>
-          </a:fontRef>
-        </p:style>
-        <p:txBody>
-          <a:bodyPr rtlCol="0" anchor="ctr"/>
-          <a:lstStyle/>
-          <a:p>
-            <a:pPr algn="ctr"/>
-          </a:p>
-        </p:txBody>
-      </p:sp>
-      <p:sp>
-        <p:nvSpPr>
-          <p:cNvPr id="54" name="TextBox 53"/>
-          <p:cNvSpPr txBox="1"/>
-          <p:nvPr/>
-        </p:nvSpPr>
-        <p:spPr>
-          <a:xfrm>
-            <a:off x="365760" y="6565392"/>
-            <a:ext cx="11430000" cy="256032"/>
-          </a:xfrm>
-          <a:prstGeom prst="rect">
-            <a:avLst/>
-          </a:prstGeom>
-          <a:noFill/>
-        </p:spPr>
-        <p:txBody>
-          <a:bodyPr wrap="square">
-            <a:spAutoFit/>
-          </a:bodyPr>
-          <a:lstStyle/>
-          <a:p>
-            <a:pPr algn="ctr"/>
-            <a:r>
-              <a:rPr sz="800" b="0" i="0">
-                <a:solidFill>
-                  <a:srgbClr val="FFFFFF"/>
-                </a:solidFill>
-              </a:rPr>
-              <a:t>amigo.ai</a:t>
-            </a:r>
-          </a:p>
-        </p:txBody>
-      </p:sp>
     </p:spTree>
   </p:cSld>
   <p:clrMapOvr>
@@ -12029,83 +11798,6 @@
                 </a:solidFill>
               </a:rPr>
               <a:t>Flag at-risk patients and gain visibility into population health across all 6 home health cities</a:t>
-            </a:r>
-          </a:p>
-        </p:txBody>
-      </p:sp>
-      <p:sp>
-        <p:nvSpPr>
-          <p:cNvPr id="57" name="Rectangle 56"/>
-          <p:cNvSpPr/>
-          <p:nvPr/>
-        </p:nvSpPr>
-        <p:spPr>
-          <a:xfrm>
-            <a:off x="0" y="6537960"/>
-            <a:ext cx="12188952" cy="320040"/>
-          </a:xfrm>
-          <a:prstGeom prst="rect">
-            <a:avLst/>
-          </a:prstGeom>
-          <a:solidFill>
-            <a:srgbClr val="963324"/>
-          </a:solidFill>
-          <a:ln>
-            <a:noFill/>
-          </a:ln>
-        </p:spPr>
-        <p:style>
-          <a:lnRef idx="1">
-            <a:schemeClr val="accent1"/>
-          </a:lnRef>
-          <a:fillRef idx="3">
-            <a:schemeClr val="accent1"/>
-          </a:fillRef>
-          <a:effectRef idx="2">
-            <a:schemeClr val="accent1"/>
-          </a:effectRef>
-          <a:fontRef idx="minor">
-            <a:schemeClr val="lt1"/>
-          </a:fontRef>
-        </p:style>
-        <p:txBody>
-          <a:bodyPr rtlCol="0" anchor="ctr"/>
-          <a:lstStyle/>
-          <a:p>
-            <a:pPr algn="ctr"/>
-          </a:p>
-        </p:txBody>
-      </p:sp>
-      <p:sp>
-        <p:nvSpPr>
-          <p:cNvPr id="58" name="TextBox 57"/>
-          <p:cNvSpPr txBox="1"/>
-          <p:nvPr/>
-        </p:nvSpPr>
-        <p:spPr>
-          <a:xfrm>
-            <a:off x="365760" y="6565392"/>
-            <a:ext cx="11430000" cy="256032"/>
-          </a:xfrm>
-          <a:prstGeom prst="rect">
-            <a:avLst/>
-          </a:prstGeom>
-          <a:noFill/>
-        </p:spPr>
-        <p:txBody>
-          <a:bodyPr wrap="square">
-            <a:spAutoFit/>
-          </a:bodyPr>
-          <a:lstStyle/>
-          <a:p>
-            <a:pPr algn="ctr"/>
-            <a:r>
-              <a:rPr sz="800" b="0" i="0">
-                <a:solidFill>
-                  <a:srgbClr val="FFCCBB"/>
-                </a:solidFill>
-              </a:rPr>
-              <a:t>amigo.ai</a:t>
             </a:r>
           </a:p>
         </p:txBody>

</xml_diff>